<commit_message>
feat: improve PPT style candidate polish
</commit_message>
<xml_diff>
--- a/effect-tests/style-candidate-editable-samples/samples/style-sample-data-analytics.pptx
+++ b/effect-tests/style-candidate-editable-samples/samples/style-sample-data-analytics.pptx
@@ -975,8 +975,8 @@
         </p:nvSpPr>
         <p:spPr>
           <a:xfrm>
-            <a:off x="658368" y="749808"/>
-            <a:ext cx="5486400" cy="777240"/>
+            <a:off x="658368" y="694944"/>
+            <a:ext cx="5623560" cy="777240"/>
           </a:xfrm>
           <a:prstGeom prst="rect">
             <a:avLst/>
@@ -1016,7 +1016,7 @@
         </p:nvSpPr>
         <p:spPr>
           <a:xfrm>
-            <a:off x="694944" y="1536192"/>
+            <a:off x="694944" y="1463040"/>
             <a:ext cx="4114800" cy="228600"/>
           </a:xfrm>
           <a:prstGeom prst="rect">
@@ -1057,23 +1057,23 @@
         </p:nvSpPr>
         <p:spPr>
           <a:xfrm>
-            <a:off x="685800" y="2029968"/>
-            <a:ext cx="5074920" cy="1874520"/>
+            <a:off x="676656" y="1938528"/>
+            <a:ext cx="4983480" cy="1938528"/>
           </a:xfrm>
           <a:prstGeom prst="roundRect">
             <a:avLst>
-              <a:gd name="adj" fmla="val 3902"/>
+              <a:gd name="adj" fmla="val 3774"/>
             </a:avLst>
           </a:prstGeom>
           <a:solidFill>
-            <a:srgbClr val="071B34">
-              <a:alpha val="92000"/>
+            <a:srgbClr val="061C3A">
+              <a:alpha val="78000"/>
             </a:srgbClr>
           </a:solidFill>
           <a:ln w="12700">
             <a:solidFill>
-              <a:srgbClr val="6C72FF">
-                <a:alpha val="70000"/>
+              <a:srgbClr val="12C7D6">
+                <a:alpha val="54000"/>
               </a:srgbClr>
             </a:solidFill>
             <a:prstDash val="solid"/>
@@ -1088,7 +1088,7 @@
         </p:nvSpPr>
         <p:spPr>
           <a:xfrm>
-            <a:off x="932688" y="2267712"/>
+            <a:off x="932688" y="2231136"/>
             <a:ext cx="1645920" cy="256032"/>
           </a:xfrm>
           <a:prstGeom prst="rect">
@@ -1171,7 +1171,7 @@
         <p:spPr>
           <a:xfrm>
             <a:off x="960120" y="3493008"/>
-            <a:ext cx="82296" cy="82296"/>
+            <a:ext cx="73152" cy="73152"/>
           </a:xfrm>
           <a:prstGeom prst="ellipse">
             <a:avLst/>
@@ -1197,8 +1197,8 @@
         </p:nvSpPr>
         <p:spPr>
           <a:xfrm>
-            <a:off x="1115568" y="3456432"/>
-            <a:ext cx="3474720" cy="146304"/>
+            <a:off x="1124712" y="3438144"/>
+            <a:ext cx="3474720" cy="164592"/>
           </a:xfrm>
           <a:prstGeom prst="rect">
             <a:avLst/>
@@ -1238,8 +1238,8 @@
         </p:nvSpPr>
         <p:spPr>
           <a:xfrm>
-            <a:off x="960120" y="3749040"/>
-            <a:ext cx="82296" cy="82296"/>
+            <a:off x="960120" y="3767328"/>
+            <a:ext cx="73152" cy="73152"/>
           </a:xfrm>
           <a:prstGeom prst="ellipse">
             <a:avLst/>
@@ -1265,8 +1265,8 @@
         </p:nvSpPr>
         <p:spPr>
           <a:xfrm>
-            <a:off x="1115568" y="3712464"/>
-            <a:ext cx="3474720" cy="146304"/>
+            <a:off x="1124712" y="3712464"/>
+            <a:ext cx="3474720" cy="164592"/>
           </a:xfrm>
           <a:prstGeom prst="rect">
             <a:avLst/>
@@ -1306,8 +1306,8 @@
         </p:nvSpPr>
         <p:spPr>
           <a:xfrm>
-            <a:off x="960120" y="4005072"/>
-            <a:ext cx="82296" cy="82296"/>
+            <a:off x="960120" y="4041648"/>
+            <a:ext cx="73152" cy="73152"/>
           </a:xfrm>
           <a:prstGeom prst="ellipse">
             <a:avLst/>
@@ -1333,8 +1333,8 @@
         </p:nvSpPr>
         <p:spPr>
           <a:xfrm>
-            <a:off x="1115568" y="3968496"/>
-            <a:ext cx="3474720" cy="146304"/>
+            <a:off x="1124712" y="3986784"/>
+            <a:ext cx="3474720" cy="164592"/>
           </a:xfrm>
           <a:prstGeom prst="rect">
             <a:avLst/>
@@ -1374,23 +1374,23 @@
         </p:nvSpPr>
         <p:spPr>
           <a:xfrm>
-            <a:off x="713232" y="4315968"/>
-            <a:ext cx="1417320" cy="841248"/>
+            <a:off x="713232" y="4498848"/>
+            <a:ext cx="1417320" cy="749808"/>
           </a:xfrm>
           <a:prstGeom prst="roundRect">
             <a:avLst>
-              <a:gd name="adj" fmla="val 8696"/>
+              <a:gd name="adj" fmla="val 9756"/>
             </a:avLst>
           </a:prstGeom>
           <a:solidFill>
-            <a:srgbClr val="071B34">
-              <a:alpha val="92000"/>
+            <a:srgbClr val="08213C">
+              <a:alpha val="78000"/>
             </a:srgbClr>
           </a:solidFill>
           <a:ln w="12700">
             <a:solidFill>
               <a:srgbClr val="6C72FF">
-                <a:alpha val="90000"/>
+                <a:alpha val="75000"/>
               </a:srgbClr>
             </a:solidFill>
             <a:prstDash val="solid"/>
@@ -1405,8 +1405,8 @@
         </p:nvSpPr>
         <p:spPr>
           <a:xfrm>
-            <a:off x="877824" y="4480560"/>
-            <a:ext cx="1088136" cy="292608"/>
+            <a:off x="841248" y="4590288"/>
+            <a:ext cx="1161288" cy="344912"/>
           </a:xfrm>
           <a:prstGeom prst="rect">
             <a:avLst/>
@@ -1424,7 +1424,7 @@
               <a:buNone/>
             </a:pPr>
             <a:r>
-              <a:rPr lang="en-US" sz="2100" b="1" dirty="0">
+              <a:rPr lang="en-US" sz="1800" b="1" dirty="0">
                 <a:solidFill>
                   <a:srgbClr val="6C72FF"/>
                 </a:solidFill>
@@ -1434,7 +1434,7 @@
               </a:rPr>
               <a:t>73%</a:t>
             </a:r>
-            <a:endParaRPr lang="en-US" sz="2100" dirty="0"/>
+            <a:endParaRPr lang="en-US" sz="1800" dirty="0"/>
           </a:p>
         </p:txBody>
       </p:sp>
@@ -1446,8 +1446,8 @@
         </p:nvSpPr>
         <p:spPr>
           <a:xfrm>
-            <a:off x="877824" y="4828032"/>
-            <a:ext cx="1088136" cy="256032"/>
+            <a:off x="841248" y="4933737"/>
+            <a:ext cx="1161288" cy="194950"/>
           </a:xfrm>
           <a:prstGeom prst="rect">
             <a:avLst/>
@@ -1465,7 +1465,7 @@
               <a:buNone/>
             </a:pPr>
             <a:r>
-              <a:rPr lang="en-US" sz="950" b="1" dirty="0">
+              <a:rPr lang="en-US" sz="760" b="1" dirty="0">
                 <a:solidFill>
                   <a:srgbClr val="FFFFFF"/>
                 </a:solidFill>
@@ -1475,7 +1475,7 @@
               </a:rPr>
               <a:t>企业已进入试点</a:t>
             </a:r>
-            <a:endParaRPr lang="en-US" sz="950" dirty="0"/>
+            <a:endParaRPr lang="en-US" sz="760" dirty="0"/>
           </a:p>
         </p:txBody>
       </p:sp>
@@ -1487,23 +1487,23 @@
         </p:nvSpPr>
         <p:spPr>
           <a:xfrm>
-            <a:off x="2395728" y="4315968"/>
-            <a:ext cx="1417320" cy="841248"/>
+            <a:off x="2395728" y="4498848"/>
+            <a:ext cx="1417320" cy="749808"/>
           </a:xfrm>
           <a:prstGeom prst="roundRect">
             <a:avLst>
-              <a:gd name="adj" fmla="val 8696"/>
+              <a:gd name="adj" fmla="val 9756"/>
             </a:avLst>
           </a:prstGeom>
           <a:solidFill>
-            <a:srgbClr val="071B34">
-              <a:alpha val="92000"/>
+            <a:srgbClr val="08213C">
+              <a:alpha val="78000"/>
             </a:srgbClr>
           </a:solidFill>
           <a:ln w="12700">
             <a:solidFill>
               <a:srgbClr val="12C7D6">
-                <a:alpha val="90000"/>
+                <a:alpha val="75000"/>
               </a:srgbClr>
             </a:solidFill>
             <a:prstDash val="solid"/>
@@ -1518,8 +1518,8 @@
         </p:nvSpPr>
         <p:spPr>
           <a:xfrm>
-            <a:off x="2560320" y="4480560"/>
-            <a:ext cx="1088136" cy="292608"/>
+            <a:off x="2523744" y="4590288"/>
+            <a:ext cx="1161288" cy="344912"/>
           </a:xfrm>
           <a:prstGeom prst="rect">
             <a:avLst/>
@@ -1537,7 +1537,7 @@
               <a:buNone/>
             </a:pPr>
             <a:r>
-              <a:rPr lang="en-US" sz="2100" b="1" dirty="0">
+              <a:rPr lang="en-US" sz="1800" b="1" dirty="0">
                 <a:solidFill>
                   <a:srgbClr val="12C7D6"/>
                 </a:solidFill>
@@ -1547,7 +1547,7 @@
               </a:rPr>
               <a:t>3x</a:t>
             </a:r>
-            <a:endParaRPr lang="en-US" sz="2100" dirty="0"/>
+            <a:endParaRPr lang="en-US" sz="1800" dirty="0"/>
           </a:p>
         </p:txBody>
       </p:sp>
@@ -1559,8 +1559,8 @@
         </p:nvSpPr>
         <p:spPr>
           <a:xfrm>
-            <a:off x="2560320" y="4828032"/>
-            <a:ext cx="1088136" cy="256032"/>
+            <a:off x="2523744" y="4933737"/>
+            <a:ext cx="1161288" cy="194950"/>
           </a:xfrm>
           <a:prstGeom prst="rect">
             <a:avLst/>
@@ -1578,7 +1578,7 @@
               <a:buNone/>
             </a:pPr>
             <a:r>
-              <a:rPr lang="en-US" sz="950" b="1" dirty="0">
+              <a:rPr lang="en-US" sz="760" b="1" dirty="0">
                 <a:solidFill>
                   <a:srgbClr val="FFFFFF"/>
                 </a:solidFill>
@@ -1588,7 +1588,7 @@
               </a:rPr>
               <a:t>高频任务提效</a:t>
             </a:r>
-            <a:endParaRPr lang="en-US" sz="950" dirty="0"/>
+            <a:endParaRPr lang="en-US" sz="760" dirty="0"/>
           </a:p>
         </p:txBody>
       </p:sp>
@@ -1600,23 +1600,23 @@
         </p:nvSpPr>
         <p:spPr>
           <a:xfrm>
-            <a:off x="4078224" y="4315968"/>
-            <a:ext cx="1417320" cy="841248"/>
+            <a:off x="4078224" y="4498848"/>
+            <a:ext cx="1417320" cy="749808"/>
           </a:xfrm>
           <a:prstGeom prst="roundRect">
             <a:avLst>
-              <a:gd name="adj" fmla="val 8696"/>
+              <a:gd name="adj" fmla="val 9756"/>
             </a:avLst>
           </a:prstGeom>
           <a:solidFill>
-            <a:srgbClr val="071B34">
-              <a:alpha val="92000"/>
+            <a:srgbClr val="08213C">
+              <a:alpha val="78000"/>
             </a:srgbClr>
           </a:solidFill>
           <a:ln w="12700">
             <a:solidFill>
               <a:srgbClr val="6C72FF">
-                <a:alpha val="90000"/>
+                <a:alpha val="75000"/>
               </a:srgbClr>
             </a:solidFill>
             <a:prstDash val="solid"/>
@@ -1631,8 +1631,8 @@
         </p:nvSpPr>
         <p:spPr>
           <a:xfrm>
-            <a:off x="4242816" y="4480560"/>
-            <a:ext cx="1088136" cy="292608"/>
+            <a:off x="4206240" y="4590288"/>
+            <a:ext cx="1161288" cy="344912"/>
           </a:xfrm>
           <a:prstGeom prst="rect">
             <a:avLst/>
@@ -1650,7 +1650,7 @@
               <a:buNone/>
             </a:pPr>
             <a:r>
-              <a:rPr lang="en-US" sz="2100" b="1" dirty="0">
+              <a:rPr lang="en-US" sz="1800" b="1" dirty="0">
                 <a:solidFill>
                   <a:srgbClr val="6C72FF"/>
                 </a:solidFill>
@@ -1660,7 +1660,7 @@
               </a:rPr>
               <a:t>2026</a:t>
             </a:r>
-            <a:endParaRPr lang="en-US" sz="2100" dirty="0"/>
+            <a:endParaRPr lang="en-US" sz="1800" dirty="0"/>
           </a:p>
         </p:txBody>
       </p:sp>
@@ -1672,8 +1672,8 @@
         </p:nvSpPr>
         <p:spPr>
           <a:xfrm>
-            <a:off x="4242816" y="4828032"/>
-            <a:ext cx="1088136" cy="256032"/>
+            <a:off x="4206240" y="4933737"/>
+            <a:ext cx="1161288" cy="194950"/>
           </a:xfrm>
           <a:prstGeom prst="rect">
             <a:avLst/>
@@ -1691,7 +1691,7 @@
               <a:buNone/>
             </a:pPr>
             <a:r>
-              <a:rPr lang="en-US" sz="950" b="1" dirty="0">
+              <a:rPr lang="en-US" sz="760" b="1" dirty="0">
                 <a:solidFill>
                   <a:srgbClr val="FFFFFF"/>
                 </a:solidFill>
@@ -1701,7 +1701,7 @@
               </a:rPr>
               <a:t>规模化落地窗口</a:t>
             </a:r>
-            <a:endParaRPr lang="en-US" sz="950" dirty="0"/>
+            <a:endParaRPr lang="en-US" sz="760" dirty="0"/>
           </a:p>
         </p:txBody>
       </p:sp>
@@ -1713,23 +1713,23 @@
         </p:nvSpPr>
         <p:spPr>
           <a:xfrm>
-            <a:off x="6720840" y="1051560"/>
-            <a:ext cx="4389120" cy="4251960"/>
+            <a:off x="6583680" y="1097280"/>
+            <a:ext cx="4498848" cy="4187952"/>
           </a:xfrm>
           <a:prstGeom prst="roundRect">
             <a:avLst>
-              <a:gd name="adj" fmla="val 1720"/>
+              <a:gd name="adj" fmla="val 1747"/>
             </a:avLst>
           </a:prstGeom>
           <a:solidFill>
-            <a:srgbClr val="071B34">
-              <a:alpha val="92000"/>
+            <a:srgbClr val="04192F">
+              <a:alpha val="76000"/>
             </a:srgbClr>
           </a:solidFill>
           <a:ln w="12700">
             <a:solidFill>
               <a:srgbClr val="12C7D6">
-                <a:alpha val="66000"/>
+                <a:alpha val="58000"/>
               </a:srgbClr>
             </a:solidFill>
             <a:prstDash val="solid"/>
@@ -1744,7 +1744,7 @@
         </p:nvSpPr>
         <p:spPr>
           <a:xfrm>
-            <a:off x="7059168" y="1335024"/>
+            <a:off x="6949440" y="1353312"/>
             <a:ext cx="2011680" cy="237744"/>
           </a:xfrm>
           <a:prstGeom prst="rect">
@@ -1785,8 +1785,33 @@
         </p:nvSpPr>
         <p:spPr>
           <a:xfrm>
-            <a:off x="7260336" y="3055193"/>
-            <a:ext cx="628650" cy="821863"/>
+            <a:off x="6903720" y="3895344"/>
+            <a:ext cx="3611880" cy="0"/>
+          </a:xfrm>
+          <a:prstGeom prst="line">
+            <a:avLst/>
+          </a:prstGeom>
+          <a:noFill/>
+          <a:ln w="12700">
+            <a:solidFill>
+              <a:srgbClr val="2E6F9E">
+                <a:alpha val="70000"/>
+              </a:srgbClr>
+            </a:solidFill>
+            <a:prstDash val="solid"/>
+          </a:ln>
+        </p:spPr>
+      </p:sp>
+      <p:sp>
+        <p:nvSpPr>
+          <p:cNvPr id="28" name="Shape 25"/>
+          <p:cNvSpPr/>
+          <p:nvPr/>
+        </p:nvSpPr>
+        <p:spPr>
+          <a:xfrm>
+            <a:off x="7104888" y="3065800"/>
+            <a:ext cx="651510" cy="829544"/>
           </a:xfrm>
           <a:prstGeom prst="rect">
             <a:avLst/>
@@ -1806,14 +1831,14 @@
       </p:sp>
       <p:sp>
         <p:nvSpPr>
-          <p:cNvPr id="28" name="Text 25"/>
-          <p:cNvSpPr/>
-          <p:nvPr/>
-        </p:nvSpPr>
-        <p:spPr>
-          <a:xfrm>
-            <a:off x="7223760" y="4005072"/>
-            <a:ext cx="701802" cy="164592"/>
+          <p:cNvPr id="29" name="Text 26"/>
+          <p:cNvSpPr/>
+          <p:nvPr/>
+        </p:nvSpPr>
+        <p:spPr>
+          <a:xfrm>
+            <a:off x="7068312" y="4023360"/>
+            <a:ext cx="724662" cy="164592"/>
           </a:xfrm>
           <a:prstGeom prst="rect">
             <a:avLst/>
@@ -1847,14 +1872,14 @@
       </p:sp>
       <p:sp>
         <p:nvSpPr>
-          <p:cNvPr id="29" name="Shape 26"/>
-          <p:cNvSpPr/>
-          <p:nvPr/>
-        </p:nvSpPr>
-        <p:spPr>
-          <a:xfrm>
-            <a:off x="8090154" y="2624694"/>
-            <a:ext cx="628650" cy="1252362"/>
+          <p:cNvPr id="30" name="Shape 27"/>
+          <p:cNvSpPr/>
+          <p:nvPr/>
+        </p:nvSpPr>
+        <p:spPr>
+          <a:xfrm>
+            <a:off x="7957566" y="2631277"/>
+            <a:ext cx="651510" cy="1264067"/>
           </a:xfrm>
           <a:prstGeom prst="rect">
             <a:avLst/>
@@ -1874,14 +1899,14 @@
       </p:sp>
       <p:sp>
         <p:nvSpPr>
-          <p:cNvPr id="30" name="Text 27"/>
-          <p:cNvSpPr/>
-          <p:nvPr/>
-        </p:nvSpPr>
-        <p:spPr>
-          <a:xfrm>
-            <a:off x="8053578" y="4005072"/>
-            <a:ext cx="701802" cy="164592"/>
+          <p:cNvPr id="31" name="Text 28"/>
+          <p:cNvSpPr/>
+          <p:nvPr/>
+        </p:nvSpPr>
+        <p:spPr>
+          <a:xfrm>
+            <a:off x="7920990" y="4023360"/>
+            <a:ext cx="724662" cy="164592"/>
           </a:xfrm>
           <a:prstGeom prst="rect">
             <a:avLst/>
@@ -1915,14 +1940,14 @@
       </p:sp>
       <p:sp>
         <p:nvSpPr>
-          <p:cNvPr id="31" name="Shape 28"/>
-          <p:cNvSpPr/>
-          <p:nvPr/>
-        </p:nvSpPr>
-        <p:spPr>
-          <a:xfrm>
-            <a:off x="8919972" y="2350740"/>
-            <a:ext cx="628650" cy="1526316"/>
+          <p:cNvPr id="32" name="Shape 29"/>
+          <p:cNvSpPr/>
+          <p:nvPr/>
+        </p:nvSpPr>
+        <p:spPr>
+          <a:xfrm>
+            <a:off x="8810244" y="2354763"/>
+            <a:ext cx="651510" cy="1540581"/>
           </a:xfrm>
           <a:prstGeom prst="rect">
             <a:avLst/>
@@ -1942,14 +1967,14 @@
       </p:sp>
       <p:sp>
         <p:nvSpPr>
-          <p:cNvPr id="32" name="Text 29"/>
-          <p:cNvSpPr/>
-          <p:nvPr/>
-        </p:nvSpPr>
-        <p:spPr>
-          <a:xfrm>
-            <a:off x="8883396" y="4005072"/>
-            <a:ext cx="701802" cy="164592"/>
+          <p:cNvPr id="33" name="Text 30"/>
+          <p:cNvSpPr/>
+          <p:nvPr/>
+        </p:nvSpPr>
+        <p:spPr>
+          <a:xfrm>
+            <a:off x="8773668" y="4023360"/>
+            <a:ext cx="724662" cy="164592"/>
           </a:xfrm>
           <a:prstGeom prst="rect">
             <a:avLst/>
@@ -1983,14 +2008,14 @@
       </p:sp>
       <p:sp>
         <p:nvSpPr>
-          <p:cNvPr id="33" name="Shape 30"/>
-          <p:cNvSpPr/>
-          <p:nvPr/>
-        </p:nvSpPr>
-        <p:spPr>
-          <a:xfrm>
-            <a:off x="9749790" y="2096353"/>
-            <a:ext cx="628650" cy="1780703"/>
+          <p:cNvPr id="34" name="Shape 31"/>
+          <p:cNvSpPr/>
+          <p:nvPr/>
+        </p:nvSpPr>
+        <p:spPr>
+          <a:xfrm>
+            <a:off x="9662922" y="2097999"/>
+            <a:ext cx="651510" cy="1797345"/>
           </a:xfrm>
           <a:prstGeom prst="rect">
             <a:avLst/>
@@ -2010,14 +2035,14 @@
       </p:sp>
       <p:sp>
         <p:nvSpPr>
-          <p:cNvPr id="34" name="Text 31"/>
-          <p:cNvSpPr/>
-          <p:nvPr/>
-        </p:nvSpPr>
-        <p:spPr>
-          <a:xfrm>
-            <a:off x="9713214" y="4005072"/>
-            <a:ext cx="701802" cy="164592"/>
+          <p:cNvPr id="35" name="Text 32"/>
+          <p:cNvSpPr/>
+          <p:nvPr/>
+        </p:nvSpPr>
+        <p:spPr>
+          <a:xfrm>
+            <a:off x="9626346" y="4023360"/>
+            <a:ext cx="724662" cy="164592"/>
           </a:xfrm>
           <a:prstGeom prst="rect">
             <a:avLst/>
@@ -2051,14 +2076,39 @@
       </p:sp>
       <p:sp>
         <p:nvSpPr>
-          <p:cNvPr id="35" name="Text 32"/>
-          <p:cNvSpPr/>
-          <p:nvPr/>
-        </p:nvSpPr>
-        <p:spPr>
-          <a:xfrm>
-            <a:off x="7059168" y="4681728"/>
-            <a:ext cx="3520440" cy="256032"/>
+          <p:cNvPr id="36" name="Shape 33"/>
+          <p:cNvSpPr/>
+          <p:nvPr/>
+        </p:nvSpPr>
+        <p:spPr>
+          <a:xfrm>
+            <a:off x="6949440" y="4809744"/>
+            <a:ext cx="475488" cy="0"/>
+          </a:xfrm>
+          <a:prstGeom prst="line">
+            <a:avLst/>
+          </a:prstGeom>
+          <a:noFill/>
+          <a:ln w="19050">
+            <a:solidFill>
+              <a:srgbClr val="6C72FF">
+                <a:alpha val="90000"/>
+              </a:srgbClr>
+            </a:solidFill>
+            <a:prstDash val="solid"/>
+          </a:ln>
+        </p:spPr>
+      </p:sp>
+      <p:sp>
+        <p:nvSpPr>
+          <p:cNvPr id="37" name="Text 34"/>
+          <p:cNvSpPr/>
+          <p:nvPr/>
+        </p:nvSpPr>
+        <p:spPr>
+          <a:xfrm>
+            <a:off x="7571232" y="4718304"/>
+            <a:ext cx="3429000" cy="164592"/>
           </a:xfrm>
           <a:prstGeom prst="rect">
             <a:avLst/>
@@ -2076,7 +2126,7 @@
               <a:buNone/>
             </a:pPr>
             <a:r>
-              <a:rPr lang="en-US" sz="840" dirty="0">
+              <a:rPr lang="en-US" sz="740" dirty="0">
                 <a:solidFill>
                   <a:srgbClr val="A7C3D9"/>
                 </a:solidFill>
@@ -2084,15 +2134,15 @@
                 <a:ea typeface="PingFang SC" pitchFamily="34" charset="-122"/>
                 <a:cs typeface="PingFang SC" pitchFamily="34" charset="-120"/>
               </a:rPr>
-              <a:t>样张中的文字、数字和图表标签均为 PPT 可编辑对象</a:t>
-            </a:r>
-            <a:endParaRPr lang="en-US" sz="840" dirty="0"/>
-          </a:p>
-        </p:txBody>
-      </p:sp>
-      <p:sp>
-        <p:nvSpPr>
-          <p:cNvPr id="36" name="Text 33"/>
+              <a:t>文字、数字和图表标签均为 PPT 可编辑对象</a:t>
+            </a:r>
+            <a:endParaRPr lang="en-US" sz="740" dirty="0"/>
+          </a:p>
+        </p:txBody>
+      </p:sp>
+      <p:sp>
+        <p:nvSpPr>
+          <p:cNvPr id="38" name="Text 35"/>
           <p:cNvSpPr/>
           <p:nvPr/>
         </p:nvSpPr>
@@ -2117,7 +2167,7 @@
               <a:buNone/>
             </a:pPr>
             <a:r>
-              <a:rPr lang="en-US" sz="750" b="1" dirty="0">
+              <a:rPr lang="en-US" sz="720" b="1" dirty="0">
                 <a:solidFill>
                   <a:srgbClr val="6C72FF"/>
                 </a:solidFill>
@@ -2127,7 +2177,7 @@
               </a:rPr>
               <a:t>数据分析</a:t>
             </a:r>
-            <a:endParaRPr lang="en-US" sz="750" dirty="0"/>
+            <a:endParaRPr lang="en-US" sz="720" dirty="0"/>
           </a:p>
         </p:txBody>
       </p:sp>

</xml_diff>

<commit_message>
feat: remove large PPT style candidate boxes
</commit_message>
<xml_diff>
--- a/effect-tests/style-candidate-editable-samples/samples/style-sample-data-analytics.pptx
+++ b/effect-tests/style-candidate-editable-samples/samples/style-sample-data-analytics.pptx
@@ -1057,23 +1057,17 @@
         </p:nvSpPr>
         <p:spPr>
           <a:xfrm>
-            <a:off x="676656" y="1938528"/>
-            <a:ext cx="4983480" cy="1938528"/>
-          </a:xfrm>
-          <a:prstGeom prst="roundRect">
-            <a:avLst>
-              <a:gd name="adj" fmla="val 3774"/>
-            </a:avLst>
-          </a:prstGeom>
-          <a:solidFill>
-            <a:srgbClr val="061C3A">
-              <a:alpha val="78000"/>
-            </a:srgbClr>
-          </a:solidFill>
-          <a:ln w="12700">
+            <a:off x="749808" y="1938528"/>
+            <a:ext cx="4251960" cy="0"/>
+          </a:xfrm>
+          <a:prstGeom prst="line">
+            <a:avLst/>
+          </a:prstGeom>
+          <a:noFill/>
+          <a:ln w="15240">
             <a:solidFill>
-              <a:srgbClr val="12C7D6">
-                <a:alpha val="54000"/>
+              <a:srgbClr val="6C72FF">
+                <a:alpha val="65000"/>
               </a:srgbClr>
             </a:solidFill>
             <a:prstDash val="solid"/>
@@ -1088,7 +1082,7 @@
         </p:nvSpPr>
         <p:spPr>
           <a:xfrm>
-            <a:off x="932688" y="2231136"/>
+            <a:off x="749808" y="2121408"/>
             <a:ext cx="1645920" cy="256032"/>
           </a:xfrm>
           <a:prstGeom prst="rect">
@@ -1129,7 +1123,7 @@
         </p:nvSpPr>
         <p:spPr>
           <a:xfrm>
-            <a:off x="932688" y="2670048"/>
+            <a:off x="749808" y="2624328"/>
             <a:ext cx="4343400" cy="603504"/>
           </a:xfrm>
           <a:prstGeom prst="rect">
@@ -1170,7 +1164,7 @@
         </p:nvSpPr>
         <p:spPr>
           <a:xfrm>
-            <a:off x="960120" y="3493008"/>
+            <a:off x="768096" y="3438144"/>
             <a:ext cx="73152" cy="73152"/>
           </a:xfrm>
           <a:prstGeom prst="ellipse">
@@ -1197,7 +1191,7 @@
         </p:nvSpPr>
         <p:spPr>
           <a:xfrm>
-            <a:off x="1124712" y="3438144"/>
+            <a:off x="932688" y="3383280"/>
             <a:ext cx="3474720" cy="164592"/>
           </a:xfrm>
           <a:prstGeom prst="rect">
@@ -1238,7 +1232,7 @@
         </p:nvSpPr>
         <p:spPr>
           <a:xfrm>
-            <a:off x="960120" y="3767328"/>
+            <a:off x="768096" y="3730752"/>
             <a:ext cx="73152" cy="73152"/>
           </a:xfrm>
           <a:prstGeom prst="ellipse">
@@ -1265,7 +1259,7 @@
         </p:nvSpPr>
         <p:spPr>
           <a:xfrm>
-            <a:off x="1124712" y="3712464"/>
+            <a:off x="932688" y="3675888"/>
             <a:ext cx="3474720" cy="164592"/>
           </a:xfrm>
           <a:prstGeom prst="rect">
@@ -1306,7 +1300,7 @@
         </p:nvSpPr>
         <p:spPr>
           <a:xfrm>
-            <a:off x="960120" y="4041648"/>
+            <a:off x="768096" y="4023360"/>
             <a:ext cx="73152" cy="73152"/>
           </a:xfrm>
           <a:prstGeom prst="ellipse">
@@ -1333,7 +1327,7 @@
         </p:nvSpPr>
         <p:spPr>
           <a:xfrm>
-            <a:off x="1124712" y="3986784"/>
+            <a:off x="932688" y="3968496"/>
             <a:ext cx="3474720" cy="164592"/>
           </a:xfrm>
           <a:prstGeom prst="rect">
@@ -1374,23 +1368,23 @@
         </p:nvSpPr>
         <p:spPr>
           <a:xfrm>
-            <a:off x="713232" y="4498848"/>
-            <a:ext cx="1417320" cy="749808"/>
+            <a:off x="713232" y="4736592"/>
+            <a:ext cx="1353312" cy="621792"/>
           </a:xfrm>
           <a:prstGeom prst="roundRect">
             <a:avLst>
-              <a:gd name="adj" fmla="val 9756"/>
+              <a:gd name="adj" fmla="val 11765"/>
             </a:avLst>
           </a:prstGeom>
           <a:solidFill>
             <a:srgbClr val="08213C">
-              <a:alpha val="78000"/>
+              <a:alpha val="70000"/>
             </a:srgbClr>
           </a:solidFill>
           <a:ln w="12700">
             <a:solidFill>
               <a:srgbClr val="6C72FF">
-                <a:alpha val="75000"/>
+                <a:alpha val="64000"/>
               </a:srgbClr>
             </a:solidFill>
             <a:prstDash val="solid"/>
@@ -1405,8 +1399,8 @@
         </p:nvSpPr>
         <p:spPr>
           <a:xfrm>
-            <a:off x="841248" y="4590288"/>
-            <a:ext cx="1161288" cy="344912"/>
+            <a:off x="841248" y="4828032"/>
+            <a:ext cx="1097280" cy="286024"/>
           </a:xfrm>
           <a:prstGeom prst="rect">
             <a:avLst/>
@@ -1446,8 +1440,8 @@
         </p:nvSpPr>
         <p:spPr>
           <a:xfrm>
-            <a:off x="841248" y="4933737"/>
-            <a:ext cx="1161288" cy="194950"/>
+            <a:off x="841248" y="5097231"/>
+            <a:ext cx="1097280" cy="161666"/>
           </a:xfrm>
           <a:prstGeom prst="rect">
             <a:avLst/>
@@ -1487,23 +1481,23 @@
         </p:nvSpPr>
         <p:spPr>
           <a:xfrm>
-            <a:off x="2395728" y="4498848"/>
-            <a:ext cx="1417320" cy="749808"/>
+            <a:off x="2395728" y="4736592"/>
+            <a:ext cx="1353312" cy="621792"/>
           </a:xfrm>
           <a:prstGeom prst="roundRect">
             <a:avLst>
-              <a:gd name="adj" fmla="val 9756"/>
+              <a:gd name="adj" fmla="val 11765"/>
             </a:avLst>
           </a:prstGeom>
           <a:solidFill>
             <a:srgbClr val="08213C">
-              <a:alpha val="78000"/>
+              <a:alpha val="70000"/>
             </a:srgbClr>
           </a:solidFill>
           <a:ln w="12700">
             <a:solidFill>
               <a:srgbClr val="12C7D6">
-                <a:alpha val="75000"/>
+                <a:alpha val="64000"/>
               </a:srgbClr>
             </a:solidFill>
             <a:prstDash val="solid"/>
@@ -1518,8 +1512,8 @@
         </p:nvSpPr>
         <p:spPr>
           <a:xfrm>
-            <a:off x="2523744" y="4590288"/>
-            <a:ext cx="1161288" cy="344912"/>
+            <a:off x="2523744" y="4828032"/>
+            <a:ext cx="1097280" cy="286024"/>
           </a:xfrm>
           <a:prstGeom prst="rect">
             <a:avLst/>
@@ -1559,8 +1553,8 @@
         </p:nvSpPr>
         <p:spPr>
           <a:xfrm>
-            <a:off x="2523744" y="4933737"/>
-            <a:ext cx="1161288" cy="194950"/>
+            <a:off x="2523744" y="5097231"/>
+            <a:ext cx="1097280" cy="161666"/>
           </a:xfrm>
           <a:prstGeom prst="rect">
             <a:avLst/>
@@ -1600,23 +1594,23 @@
         </p:nvSpPr>
         <p:spPr>
           <a:xfrm>
-            <a:off x="4078224" y="4498848"/>
-            <a:ext cx="1417320" cy="749808"/>
+            <a:off x="4078224" y="4736592"/>
+            <a:ext cx="1353312" cy="621792"/>
           </a:xfrm>
           <a:prstGeom prst="roundRect">
             <a:avLst>
-              <a:gd name="adj" fmla="val 9756"/>
+              <a:gd name="adj" fmla="val 11765"/>
             </a:avLst>
           </a:prstGeom>
           <a:solidFill>
             <a:srgbClr val="08213C">
-              <a:alpha val="78000"/>
+              <a:alpha val="70000"/>
             </a:srgbClr>
           </a:solidFill>
           <a:ln w="12700">
             <a:solidFill>
               <a:srgbClr val="6C72FF">
-                <a:alpha val="75000"/>
+                <a:alpha val="64000"/>
               </a:srgbClr>
             </a:solidFill>
             <a:prstDash val="solid"/>
@@ -1631,8 +1625,8 @@
         </p:nvSpPr>
         <p:spPr>
           <a:xfrm>
-            <a:off x="4206240" y="4590288"/>
-            <a:ext cx="1161288" cy="344912"/>
+            <a:off x="4206240" y="4828032"/>
+            <a:ext cx="1097280" cy="286024"/>
           </a:xfrm>
           <a:prstGeom prst="rect">
             <a:avLst/>
@@ -1672,8 +1666,8 @@
         </p:nvSpPr>
         <p:spPr>
           <a:xfrm>
-            <a:off x="4206240" y="4933737"/>
-            <a:ext cx="1161288" cy="194950"/>
+            <a:off x="4206240" y="5097231"/>
+            <a:ext cx="1097280" cy="161666"/>
           </a:xfrm>
           <a:prstGeom prst="rect">
             <a:avLst/>
@@ -1707,44 +1701,13 @@
       </p:sp>
       <p:sp>
         <p:nvSpPr>
-          <p:cNvPr id="25" name="Shape 22"/>
-          <p:cNvSpPr/>
-          <p:nvPr/>
-        </p:nvSpPr>
-        <p:spPr>
-          <a:xfrm>
-            <a:off x="6583680" y="1097280"/>
-            <a:ext cx="4498848" cy="4187952"/>
-          </a:xfrm>
-          <a:prstGeom prst="roundRect">
-            <a:avLst>
-              <a:gd name="adj" fmla="val 1747"/>
-            </a:avLst>
-          </a:prstGeom>
-          <a:solidFill>
-            <a:srgbClr val="04192F">
-              <a:alpha val="76000"/>
-            </a:srgbClr>
-          </a:solidFill>
-          <a:ln w="12700">
-            <a:solidFill>
-              <a:srgbClr val="12C7D6">
-                <a:alpha val="58000"/>
-              </a:srgbClr>
-            </a:solidFill>
-            <a:prstDash val="solid"/>
-          </a:ln>
-        </p:spPr>
-      </p:sp>
-      <p:sp>
-        <p:nvSpPr>
-          <p:cNvPr id="26" name="Text 23"/>
-          <p:cNvSpPr/>
-          <p:nvPr/>
-        </p:nvSpPr>
-        <p:spPr>
-          <a:xfrm>
-            <a:off x="6949440" y="1353312"/>
+          <p:cNvPr id="25" name="Text 22"/>
+          <p:cNvSpPr/>
+          <p:nvPr/>
+        </p:nvSpPr>
+        <p:spPr>
+          <a:xfrm>
+            <a:off x="6720840" y="1335024"/>
             <a:ext cx="2011680" cy="237744"/>
           </a:xfrm>
           <a:prstGeom prst="rect">
@@ -1779,14 +1742,39 @@
       </p:sp>
       <p:sp>
         <p:nvSpPr>
+          <p:cNvPr id="26" name="Shape 23"/>
+          <p:cNvSpPr/>
+          <p:nvPr/>
+        </p:nvSpPr>
+        <p:spPr>
+          <a:xfrm>
+            <a:off x="6720840" y="1719072"/>
+            <a:ext cx="3730752" cy="0"/>
+          </a:xfrm>
+          <a:prstGeom prst="line">
+            <a:avLst/>
+          </a:prstGeom>
+          <a:noFill/>
+          <a:ln w="15240">
+            <a:solidFill>
+              <a:srgbClr val="6C72FF">
+                <a:alpha val="65000"/>
+              </a:srgbClr>
+            </a:solidFill>
+            <a:prstDash val="solid"/>
+          </a:ln>
+        </p:spPr>
+      </p:sp>
+      <p:sp>
+        <p:nvSpPr>
           <p:cNvPr id="27" name="Shape 24"/>
           <p:cNvSpPr/>
           <p:nvPr/>
         </p:nvSpPr>
         <p:spPr>
           <a:xfrm>
-            <a:off x="6903720" y="3895344"/>
-            <a:ext cx="3611880" cy="0"/>
+            <a:off x="6647688" y="4151376"/>
+            <a:ext cx="3730752" cy="0"/>
           </a:xfrm>
           <a:prstGeom prst="line">
             <a:avLst/>
@@ -1810,8 +1798,8 @@
         </p:nvSpPr>
         <p:spPr>
           <a:xfrm>
-            <a:off x="7104888" y="3065800"/>
-            <a:ext cx="651510" cy="829544"/>
+            <a:off x="6848856" y="3283428"/>
+            <a:ext cx="681228" cy="867948"/>
           </a:xfrm>
           <a:prstGeom prst="rect">
             <a:avLst/>
@@ -1837,8 +1825,8 @@
         </p:nvSpPr>
         <p:spPr>
           <a:xfrm>
-            <a:off x="7068312" y="4023360"/>
-            <a:ext cx="724662" cy="164592"/>
+            <a:off x="6812280" y="4279392"/>
+            <a:ext cx="754380" cy="164592"/>
           </a:xfrm>
           <a:prstGeom prst="rect">
             <a:avLst/>
@@ -1878,8 +1866,8 @@
         </p:nvSpPr>
         <p:spPr>
           <a:xfrm>
-            <a:off x="7957566" y="2631277"/>
-            <a:ext cx="651510" cy="1264067"/>
+            <a:off x="7731252" y="2828788"/>
+            <a:ext cx="681228" cy="1322588"/>
           </a:xfrm>
           <a:prstGeom prst="rect">
             <a:avLst/>
@@ -1905,8 +1893,8 @@
         </p:nvSpPr>
         <p:spPr>
           <a:xfrm>
-            <a:off x="7920990" y="4023360"/>
-            <a:ext cx="724662" cy="164592"/>
+            <a:off x="7694676" y="4279392"/>
+            <a:ext cx="754380" cy="164592"/>
           </a:xfrm>
           <a:prstGeom prst="rect">
             <a:avLst/>
@@ -1946,8 +1934,8 @@
         </p:nvSpPr>
         <p:spPr>
           <a:xfrm>
-            <a:off x="8810244" y="2354763"/>
-            <a:ext cx="651510" cy="1540581"/>
+            <a:off x="8613648" y="2539472"/>
+            <a:ext cx="681228" cy="1611904"/>
           </a:xfrm>
           <a:prstGeom prst="rect">
             <a:avLst/>
@@ -1973,8 +1961,8 @@
         </p:nvSpPr>
         <p:spPr>
           <a:xfrm>
-            <a:off x="8773668" y="4023360"/>
-            <a:ext cx="724662" cy="164592"/>
+            <a:off x="8577072" y="4279392"/>
+            <a:ext cx="754380" cy="164592"/>
           </a:xfrm>
           <a:prstGeom prst="rect">
             <a:avLst/>
@@ -2014,8 +2002,8 @@
         </p:nvSpPr>
         <p:spPr>
           <a:xfrm>
-            <a:off x="9662922" y="2097999"/>
-            <a:ext cx="651510" cy="1797345"/>
+            <a:off x="9496044" y="2270821"/>
+            <a:ext cx="681228" cy="1880555"/>
           </a:xfrm>
           <a:prstGeom prst="rect">
             <a:avLst/>
@@ -2041,8 +2029,8 @@
         </p:nvSpPr>
         <p:spPr>
           <a:xfrm>
-            <a:off x="9626346" y="4023360"/>
-            <a:ext cx="724662" cy="164592"/>
+            <a:off x="9459468" y="4279392"/>
+            <a:ext cx="754380" cy="164592"/>
           </a:xfrm>
           <a:prstGeom prst="rect">
             <a:avLst/>
@@ -2082,7 +2070,7 @@
         </p:nvSpPr>
         <p:spPr>
           <a:xfrm>
-            <a:off x="6949440" y="4809744"/>
+            <a:off x="6720840" y="5157216"/>
             <a:ext cx="475488" cy="0"/>
           </a:xfrm>
           <a:prstGeom prst="line">
@@ -2107,7 +2095,7 @@
         </p:nvSpPr>
         <p:spPr>
           <a:xfrm>
-            <a:off x="7571232" y="4718304"/>
+            <a:off x="7342632" y="5065776"/>
             <a:ext cx="3429000" cy="164592"/>
           </a:xfrm>
           <a:prstGeom prst="rect">

</xml_diff>

<commit_message>
feat: embed PPT candidates without content frames
</commit_message>
<xml_diff>
--- a/effect-tests/style-candidate-editable-samples/samples/style-sample-data-analytics.pptx
+++ b/effect-tests/style-candidate-editable-samples/samples/style-sample-data-analytics.pptx
@@ -1369,22 +1369,16 @@
         <p:spPr>
           <a:xfrm>
             <a:off x="713232" y="4736592"/>
-            <a:ext cx="1353312" cy="621792"/>
-          </a:xfrm>
-          <a:prstGeom prst="roundRect">
-            <a:avLst>
-              <a:gd name="adj" fmla="val 11765"/>
-            </a:avLst>
-          </a:prstGeom>
-          <a:solidFill>
-            <a:srgbClr val="08213C">
-              <a:alpha val="70000"/>
-            </a:srgbClr>
-          </a:solidFill>
-          <a:ln w="12700">
+            <a:ext cx="530352" cy="0"/>
+          </a:xfrm>
+          <a:prstGeom prst="line">
+            <a:avLst/>
+          </a:prstGeom>
+          <a:noFill/>
+          <a:ln w="25400">
             <a:solidFill>
               <a:srgbClr val="6C72FF">
-                <a:alpha val="64000"/>
+                <a:alpha val="78000"/>
               </a:srgbClr>
             </a:solidFill>
             <a:prstDash val="solid"/>
@@ -1399,8 +1393,8 @@
         </p:nvSpPr>
         <p:spPr>
           <a:xfrm>
-            <a:off x="841248" y="4828032"/>
-            <a:ext cx="1097280" cy="286024"/>
+            <a:off x="713232" y="4864608"/>
+            <a:ext cx="1225296" cy="329184"/>
           </a:xfrm>
           <a:prstGeom prst="rect">
             <a:avLst/>
@@ -1440,8 +1434,8 @@
         </p:nvSpPr>
         <p:spPr>
           <a:xfrm>
-            <a:off x="841248" y="5097231"/>
-            <a:ext cx="1097280" cy="161666"/>
+            <a:off x="713232" y="5230368"/>
+            <a:ext cx="1225296" cy="228600"/>
           </a:xfrm>
           <a:prstGeom prst="rect">
             <a:avLst/>
@@ -1459,7 +1453,7 @@
               <a:buNone/>
             </a:pPr>
             <a:r>
-              <a:rPr lang="en-US" sz="760" b="1" dirty="0">
+              <a:rPr lang="en-US" sz="780" b="1" dirty="0">
                 <a:solidFill>
                   <a:srgbClr val="FFFFFF"/>
                 </a:solidFill>
@@ -1469,7 +1463,7 @@
               </a:rPr>
               <a:t>企业已进入试点</a:t>
             </a:r>
-            <a:endParaRPr lang="en-US" sz="760" dirty="0"/>
+            <a:endParaRPr lang="en-US" sz="780" dirty="0"/>
           </a:p>
         </p:txBody>
       </p:sp>
@@ -1482,22 +1476,16 @@
         <p:spPr>
           <a:xfrm>
             <a:off x="2395728" y="4736592"/>
-            <a:ext cx="1353312" cy="621792"/>
-          </a:xfrm>
-          <a:prstGeom prst="roundRect">
-            <a:avLst>
-              <a:gd name="adj" fmla="val 11765"/>
-            </a:avLst>
-          </a:prstGeom>
-          <a:solidFill>
-            <a:srgbClr val="08213C">
-              <a:alpha val="70000"/>
-            </a:srgbClr>
-          </a:solidFill>
-          <a:ln w="12700">
+            <a:ext cx="530352" cy="0"/>
+          </a:xfrm>
+          <a:prstGeom prst="line">
+            <a:avLst/>
+          </a:prstGeom>
+          <a:noFill/>
+          <a:ln w="25400">
             <a:solidFill>
               <a:srgbClr val="12C7D6">
-                <a:alpha val="64000"/>
+                <a:alpha val="78000"/>
               </a:srgbClr>
             </a:solidFill>
             <a:prstDash val="solid"/>
@@ -1512,8 +1500,8 @@
         </p:nvSpPr>
         <p:spPr>
           <a:xfrm>
-            <a:off x="2523744" y="4828032"/>
-            <a:ext cx="1097280" cy="286024"/>
+            <a:off x="2395728" y="4864608"/>
+            <a:ext cx="1225296" cy="329184"/>
           </a:xfrm>
           <a:prstGeom prst="rect">
             <a:avLst/>
@@ -1553,8 +1541,8 @@
         </p:nvSpPr>
         <p:spPr>
           <a:xfrm>
-            <a:off x="2523744" y="5097231"/>
-            <a:ext cx="1097280" cy="161666"/>
+            <a:off x="2395728" y="5230368"/>
+            <a:ext cx="1225296" cy="228600"/>
           </a:xfrm>
           <a:prstGeom prst="rect">
             <a:avLst/>
@@ -1572,7 +1560,7 @@
               <a:buNone/>
             </a:pPr>
             <a:r>
-              <a:rPr lang="en-US" sz="760" b="1" dirty="0">
+              <a:rPr lang="en-US" sz="780" b="1" dirty="0">
                 <a:solidFill>
                   <a:srgbClr val="FFFFFF"/>
                 </a:solidFill>
@@ -1582,7 +1570,7 @@
               </a:rPr>
               <a:t>高频任务提效</a:t>
             </a:r>
-            <a:endParaRPr lang="en-US" sz="760" dirty="0"/>
+            <a:endParaRPr lang="en-US" sz="780" dirty="0"/>
           </a:p>
         </p:txBody>
       </p:sp>
@@ -1595,22 +1583,16 @@
         <p:spPr>
           <a:xfrm>
             <a:off x="4078224" y="4736592"/>
-            <a:ext cx="1353312" cy="621792"/>
-          </a:xfrm>
-          <a:prstGeom prst="roundRect">
-            <a:avLst>
-              <a:gd name="adj" fmla="val 11765"/>
-            </a:avLst>
-          </a:prstGeom>
-          <a:solidFill>
-            <a:srgbClr val="08213C">
-              <a:alpha val="70000"/>
-            </a:srgbClr>
-          </a:solidFill>
-          <a:ln w="12700">
+            <a:ext cx="530352" cy="0"/>
+          </a:xfrm>
+          <a:prstGeom prst="line">
+            <a:avLst/>
+          </a:prstGeom>
+          <a:noFill/>
+          <a:ln w="25400">
             <a:solidFill>
               <a:srgbClr val="6C72FF">
-                <a:alpha val="64000"/>
+                <a:alpha val="78000"/>
               </a:srgbClr>
             </a:solidFill>
             <a:prstDash val="solid"/>
@@ -1625,8 +1607,8 @@
         </p:nvSpPr>
         <p:spPr>
           <a:xfrm>
-            <a:off x="4206240" y="4828032"/>
-            <a:ext cx="1097280" cy="286024"/>
+            <a:off x="4078224" y="4864608"/>
+            <a:ext cx="1225296" cy="329184"/>
           </a:xfrm>
           <a:prstGeom prst="rect">
             <a:avLst/>
@@ -1666,8 +1648,8 @@
         </p:nvSpPr>
         <p:spPr>
           <a:xfrm>
-            <a:off x="4206240" y="5097231"/>
-            <a:ext cx="1097280" cy="161666"/>
+            <a:off x="4078224" y="5230368"/>
+            <a:ext cx="1225296" cy="228600"/>
           </a:xfrm>
           <a:prstGeom prst="rect">
             <a:avLst/>
@@ -1685,7 +1667,7 @@
               <a:buNone/>
             </a:pPr>
             <a:r>
-              <a:rPr lang="en-US" sz="760" b="1" dirty="0">
+              <a:rPr lang="en-US" sz="780" b="1" dirty="0">
                 <a:solidFill>
                   <a:srgbClr val="FFFFFF"/>
                 </a:solidFill>
@@ -1695,7 +1677,7 @@
               </a:rPr>
               <a:t>规模化落地窗口</a:t>
             </a:r>
-            <a:endParaRPr lang="en-US" sz="760" dirty="0"/>
+            <a:endParaRPr lang="en-US" sz="780" dirty="0"/>
           </a:p>
         </p:txBody>
       </p:sp>

</xml_diff>